<commit_message>
Gera os vídeos MP4 das aulas com legendas
publicar.cjs renderiza os slides de cada aula (LibreOffice + pdftoppm),
acha as fronteiras entre cenas pelas pausas do áudio e monta um MP4
1920x1080 em que cada slide acompanha a sua narração; slides sem voz têm
tempo de leitura. Gera também legendas .srt por frase. O gerador de
slides exporta a linha do tempo por aula e corrige problemas vistos na
renderização (títulos de laboratório, número da abertura, logo sem fundo,
item único em destaque, explicações longas em slide próprio).

Co-Authored-By: Claude Opus 5.5 <noreply@anthropic.com>
</commit_message>
<xml_diff>
--- a/docs/curso/slides/m02-marco-legal.pptx
+++ b/docs/curso/slides/m02-marco-legal.pptx
@@ -4526,7 +4526,7 @@
                 <a:ea typeface="Arial" pitchFamily="34" charset="-122"/>
                 <a:cs typeface="Arial" pitchFamily="34" charset="-120"/>
               </a:rPr>
-              <a:t>7. concessionária, tarifa GD e a calculadora de Fio B</a:t>
+              <a:t>7. Concessionária, tarifa GD e a calculadora de Fio B</a:t>
             </a:r>
             <a:endParaRPr lang="en-US" sz="1200" dirty="0"/>
           </a:p>
@@ -4953,12 +4953,12 @@
         </p:nvSpPr>
         <p:spPr>
           <a:xfrm>
-            <a:off x="548640" y="1325880"/>
-            <a:ext cx="11091672" cy="3977640"/>
+            <a:off x="1463040" y="1600200"/>
+            <a:ext cx="9262872" cy="3429000"/>
           </a:xfrm>
           <a:prstGeom prst="roundRect">
             <a:avLst>
-              <a:gd name="adj" fmla="val 1839"/>
+              <a:gd name="adj" fmla="val 3200"/>
             </a:avLst>
           </a:prstGeom>
           <a:solidFill>
@@ -4971,9 +4971,9 @@
             <a:prstDash val="solid"/>
           </a:ln>
           <a:effectLst>
-            <a:outerShdw sx="100000" sy="100000" kx="0" ky="0" algn="bl" rotWithShape="0" blurRad="38100" dist="12700" dir="5400000">
+            <a:outerShdw sx="100000" sy="100000" kx="0" ky="0" algn="bl" rotWithShape="0" blurRad="50800" dist="12700" dir="5400000">
               <a:srgbClr val="000000">
-                <a:alpha val="8000"/>
+                <a:alpha val="10000"/>
               </a:srgbClr>
             </a:outerShdw>
           </a:effectLst>
@@ -4987,14 +4987,14 @@
         </p:nvSpPr>
         <p:spPr>
           <a:xfrm>
-            <a:off x="731520" y="1508760"/>
-            <a:ext cx="457200" cy="457200"/>
-          </a:xfrm>
-          <a:prstGeom prst="ellipse">
+            <a:off x="1463040" y="1600200"/>
+            <a:ext cx="128016" cy="3429000"/>
+          </a:xfrm>
+          <a:prstGeom prst="rect">
             <a:avLst/>
           </a:prstGeom>
           <a:solidFill>
-            <a:srgbClr val="1B3A6B"/>
+            <a:srgbClr val="F7A23B"/>
           </a:solidFill>
           <a:ln/>
         </p:spPr>
@@ -5007,8 +5007,8 @@
         </p:nvSpPr>
         <p:spPr>
           <a:xfrm>
-            <a:off x="731520" y="1508760"/>
-            <a:ext cx="457200" cy="457200"/>
+            <a:off x="2011680" y="1783080"/>
+            <a:ext cx="8412480" cy="3063240"/>
           </a:xfrm>
           <a:prstGeom prst="rect">
             <a:avLst/>
@@ -5024,50 +5024,9 @@
               <a:buNone/>
             </a:pPr>
             <a:r>
-              <a:rPr lang="en-US" sz="1400" b="1" dirty="0">
-                <a:solidFill>
-                  <a:srgbClr val="FFFFFF"/>
-                </a:solidFill>
-                <a:latin typeface="Arial" pitchFamily="34" charset="0"/>
-                <a:ea typeface="Arial" pitchFamily="34" charset="-122"/>
-                <a:cs typeface="Arial" pitchFamily="34" charset="-120"/>
-              </a:rPr>
-              <a:t>1</a:t>
-            </a:r>
-            <a:endParaRPr lang="en-US" sz="1400" dirty="0"/>
-          </a:p>
-        </p:txBody>
-      </p:sp>
-      <p:sp>
-        <p:nvSpPr>
-          <p:cNvPr id="12" name="Text 9"/>
-          <p:cNvSpPr/>
-          <p:nvPr/>
-        </p:nvSpPr>
-        <p:spPr>
-          <a:xfrm>
-            <a:off x="1325880" y="1435608"/>
-            <a:ext cx="10177272" cy="3758184"/>
-          </a:xfrm>
-          <a:prstGeom prst="rect">
-            <a:avLst/>
-          </a:prstGeom>
-          <a:noFill/>
-          <a:ln/>
-        </p:spPr>
-        <p:txBody>
-          <a:bodyPr wrap="square" rtlCol="0" anchor="ctr">
-            <a:normAutofit/>
-          </a:bodyPr>
-          <a:lstStyle/>
-          <a:p>
-            <a:pPr indent="0" marL="0">
-              <a:buNone/>
-            </a:pPr>
-            <a:r>
-              <a:rPr lang="en-US" sz="1800" dirty="0">
-                <a:solidFill>
-                  <a:srgbClr val="1F2937"/>
+              <a:rPr lang="en-US" sz="3200" b="1" dirty="0">
+                <a:solidFill>
+                  <a:srgbClr val="1B3A6B"/>
                 </a:solidFill>
                 <a:latin typeface="Arial" pitchFamily="34" charset="0"/>
                 <a:ea typeface="Arial" pitchFamily="34" charset="-122"/>
@@ -5075,13 +5034,13 @@
               </a:rPr>
               <a:t>EMUC — empreendimento com múltiplas unidades consumidoras: condomínios, mesma propriedade, áreas contíguas</a:t>
             </a:r>
-            <a:endParaRPr lang="en-US" sz="1800" dirty="0"/>
-          </a:p>
-        </p:txBody>
-      </p:sp>
-      <p:sp>
-        <p:nvSpPr>
-          <p:cNvPr id="13" name="Shape 10"/>
+            <a:endParaRPr lang="en-US" sz="3200" dirty="0"/>
+          </a:p>
+        </p:txBody>
+      </p:sp>
+      <p:sp>
+        <p:nvSpPr>
+          <p:cNvPr id="12" name="Shape 9"/>
           <p:cNvSpPr/>
           <p:nvPr/>
         </p:nvSpPr>
@@ -5108,7 +5067,7 @@
       </p:sp>
       <p:sp>
         <p:nvSpPr>
-          <p:cNvPr id="14" name="Shape 11"/>
+          <p:cNvPr id="13" name="Shape 10"/>
           <p:cNvSpPr/>
           <p:nvPr/>
         </p:nvSpPr>
@@ -5128,7 +5087,7 @@
       </p:sp>
       <p:sp>
         <p:nvSpPr>
-          <p:cNvPr id="15" name="Text 12"/>
+          <p:cNvPr id="14" name="Text 11"/>
           <p:cNvSpPr/>
           <p:nvPr/>
         </p:nvSpPr>
@@ -7455,7 +7414,7 @@
             <a:r>
               <a:rPr lang="en-US" sz="11000" b="1" dirty="0">
                 <a:solidFill>
-                  <a:srgbClr val="11396F"/>
+                  <a:srgbClr val="F7A23B"/>
                 </a:solidFill>
                 <a:latin typeface="Arial" pitchFamily="34" charset="0"/>
                 <a:ea typeface="Arial" pitchFamily="34" charset="-122"/>
@@ -7578,7 +7537,7 @@
                 <a:ea typeface="Arial" pitchFamily="34" charset="-122"/>
                 <a:cs typeface="Arial" pitchFamily="34" charset="-120"/>
               </a:rPr>
-              <a:t>Aula</a:t>
+              <a:t>Aula teórica</a:t>
             </a:r>
             <a:endParaRPr lang="en-US" sz="1400" dirty="0"/>
           </a:p>
@@ -8198,7 +8157,7 @@
               <a:buNone/>
             </a:pPr>
             <a:r>
-              <a:rPr lang="en-US" sz="1300" i="1" dirty="0">
+              <a:rPr lang="en-US" sz="1500" i="1" dirty="0">
                 <a:solidFill>
                   <a:srgbClr val="64748B"/>
                 </a:solidFill>
@@ -8208,7 +8167,7 @@
               </a:rPr>
               <a:t>O crédito nasce no medidor da usina, em quilowatt-hora. O valor em reais só aparece na fatura do cliente.</a:t>
             </a:r>
-            <a:endParaRPr lang="en-US" sz="1300" dirty="0"/>
+            <a:endParaRPr lang="en-US" sz="1500" dirty="0"/>
           </a:p>
         </p:txBody>
       </p:sp>
@@ -8373,7 +8332,7 @@
               <a:buNone/>
             </a:pPr>
             <a:r>
-              <a:rPr lang="en-US" sz="1300" i="1" dirty="0">
+              <a:rPr lang="en-US" sz="1500" i="1" dirty="0">
                 <a:solidFill>
                   <a:srgbClr val="64748B"/>
                 </a:solidFill>
@@ -8383,7 +8342,7 @@
               </a:rPr>
               <a:t>Os créditos são divididos pela lista de rateio, em percentuais. Se a usina gera menos, todos recebem proporcionalmente menos. E atualizar essa lista é tarefa mensal da sua operação.</a:t>
             </a:r>
-            <a:endParaRPr lang="en-US" sz="1300" dirty="0"/>
+            <a:endParaRPr lang="en-US" sz="1500" dirty="0"/>
           </a:p>
         </p:txBody>
       </p:sp>
@@ -9441,7 +9400,7 @@
               <a:buNone/>
             </a:pPr>
             <a:r>
-              <a:rPr lang="en-US" sz="1300" i="1" dirty="0">
+              <a:rPr lang="en-US" sz="1400" i="1" dirty="0">
                 <a:solidFill>
                   <a:srgbClr val="64748B"/>
                 </a:solidFill>
@@ -9451,7 +9410,7 @@
               </a:rPr>
               <a:t>Sobras ficam acumuladas por até sessenta meses. Sobra recorrente é sinal de cota alta demais.</a:t>
             </a:r>
-            <a:endParaRPr lang="en-US" sz="1300" dirty="0"/>
+            <a:endParaRPr lang="en-US" sz="1400" dirty="0"/>
           </a:p>
         </p:txBody>
       </p:sp>
@@ -9661,7 +9620,7 @@
               <a:buNone/>
             </a:pPr>
             <a:r>
-              <a:rPr lang="en-US" sz="1300" i="1" dirty="0">
+              <a:rPr lang="en-US" sz="1400" i="1" dirty="0">
                 <a:solidFill>
                   <a:srgbClr val="64748B"/>
                 </a:solidFill>
@@ -9671,7 +9630,7 @@
               </a:rPr>
               <a:t>A distribuidora mede, rateia e fatura. A sua empresa mantém o rateio, confere as faturas, cobra e paga o produtor. A fatura é a base da sua cobrança.</a:t>
             </a:r>
-            <a:endParaRPr lang="en-US" sz="1300" dirty="0"/>
+            <a:endParaRPr lang="en-US" sz="1400" dirty="0"/>
           </a:p>
         </p:txBody>
       </p:sp>
@@ -10645,7 +10604,7 @@
             <a:r>
               <a:rPr lang="en-US" sz="11000" b="1" dirty="0">
                 <a:solidFill>
-                  <a:srgbClr val="11396F"/>
+                  <a:srgbClr val="F7A23B"/>
                 </a:solidFill>
                 <a:latin typeface="Arial" pitchFamily="34" charset="0"/>
                 <a:ea typeface="Arial" pitchFamily="34" charset="-122"/>
@@ -10768,7 +10727,7 @@
                 <a:ea typeface="Arial" pitchFamily="34" charset="-122"/>
                 <a:cs typeface="Arial" pitchFamily="34" charset="-120"/>
               </a:rPr>
-              <a:t>Aula</a:t>
+              <a:t>Aula teórica</a:t>
             </a:r>
             <a:endParaRPr lang="en-US" sz="1400" dirty="0"/>
           </a:p>
@@ -11749,7 +11708,7 @@
             <a:r>
               <a:rPr lang="en-US" sz="11000" b="1" dirty="0">
                 <a:solidFill>
-                  <a:srgbClr val="11396F"/>
+                  <a:srgbClr val="F7A23B"/>
                 </a:solidFill>
                 <a:latin typeface="Arial" pitchFamily="34" charset="0"/>
                 <a:ea typeface="Arial" pitchFamily="34" charset="-122"/>
@@ -11872,7 +11831,7 @@
                 <a:ea typeface="Arial" pitchFamily="34" charset="-122"/>
                 <a:cs typeface="Arial" pitchFamily="34" charset="-120"/>
               </a:rPr>
-              <a:t>Aula</a:t>
+              <a:t>Aula teórica</a:t>
             </a:r>
             <a:endParaRPr lang="en-US" sz="1400" dirty="0"/>
           </a:p>
@@ -14522,7 +14481,7 @@
               <a:buNone/>
             </a:pPr>
             <a:r>
-              <a:rPr lang="en-US" sz="1300" i="1" dirty="0">
+              <a:rPr lang="en-US" sz="1400" i="1" dirty="0">
                 <a:solidFill>
                   <a:srgbClr val="64748B"/>
                 </a:solidFill>
@@ -14532,7 +14491,7 @@
               </a:rPr>
               <a:t>O GD três atinge usinas acima de quinhentos quilowatts com um participante concentrando vinte e cinco por cento ou mais dos créditos. Evite essa concentração.</a:t>
             </a:r>
-            <a:endParaRPr lang="en-US" sz="1300" dirty="0"/>
+            <a:endParaRPr lang="en-US" sz="1400" dirty="0"/>
           </a:p>
         </p:txBody>
       </p:sp>
@@ -14805,7 +14764,7 @@
               <a:buNone/>
             </a:pPr>
             <a:r>
-              <a:rPr lang="en-US" sz="1300" i="1" dirty="0">
+              <a:rPr lang="en-US" sz="1400" i="1" dirty="0">
                 <a:solidFill>
                   <a:srgbClr val="64748B"/>
                 </a:solidFill>
@@ -14815,7 +14774,7 @@
               </a:rPr>
               <a:t>Para enquadrar uma usina, olhe data do pedido, potência, modalidade e concentração, e confirme com a distribuidora.</a:t>
             </a:r>
-            <a:endParaRPr lang="en-US" sz="1300" dirty="0"/>
+            <a:endParaRPr lang="en-US" sz="1400" dirty="0"/>
           </a:p>
         </p:txBody>
       </p:sp>
@@ -15789,7 +15748,7 @@
             <a:r>
               <a:rPr lang="en-US" sz="11000" b="1" dirty="0">
                 <a:solidFill>
-                  <a:srgbClr val="11396F"/>
+                  <a:srgbClr val="F7A23B"/>
                 </a:solidFill>
                 <a:latin typeface="Arial" pitchFamily="34" charset="0"/>
                 <a:ea typeface="Arial" pitchFamily="34" charset="-122"/>
@@ -15912,7 +15871,7 @@
                 <a:ea typeface="Arial" pitchFamily="34" charset="-122"/>
                 <a:cs typeface="Arial" pitchFamily="34" charset="-120"/>
               </a:rPr>
-              <a:t>Aula</a:t>
+              <a:t>Aula teórica</a:t>
             </a:r>
             <a:endParaRPr lang="en-US" sz="1400" dirty="0"/>
           </a:p>
@@ -19788,7 +19747,7 @@
               <a:buNone/>
             </a:pPr>
             <a:r>
-              <a:rPr lang="en-US" sz="1300" i="1" dirty="0">
+              <a:rPr lang="en-US" sz="1500" i="1" dirty="0">
                 <a:solidFill>
                   <a:srgbClr val="64748B"/>
                 </a:solidFill>
@@ -19798,7 +19757,7 @@
               </a:rPr>
               <a:t>Geração distribuída é micro e minigeração conectada à rede da distribuidora, com compensação: quem gera recebe créditos, não dinheiro.</a:t>
             </a:r>
-            <a:endParaRPr lang="en-US" sz="1300" dirty="0"/>
+            <a:endParaRPr lang="en-US" sz="1500" dirty="0"/>
           </a:p>
         </p:txBody>
       </p:sp>
@@ -19963,7 +19922,7 @@
               <a:buNone/>
             </a:pPr>
             <a:r>
-              <a:rPr lang="en-US" sz="1300" i="1" dirty="0">
+              <a:rPr lang="en-US" sz="1500" i="1" dirty="0">
                 <a:solidFill>
                   <a:srgbClr val="64748B"/>
                 </a:solidFill>
@@ -19973,7 +19932,7 @@
               </a:rPr>
               <a:t>Tudo começou em 2012, com a criação do sistema de compensação.</a:t>
             </a:r>
-            <a:endParaRPr lang="en-US" sz="1300" dirty="0"/>
+            <a:endParaRPr lang="en-US" sz="1500" dirty="0"/>
           </a:p>
         </p:txBody>
       </p:sp>
@@ -20266,7 +20225,7 @@
               <a:buNone/>
             </a:pPr>
             <a:r>
-              <a:rPr lang="en-US" sz="1300" i="1" dirty="0">
+              <a:rPr lang="en-US" sz="1400" i="1" dirty="0">
                 <a:solidFill>
                   <a:srgbClr val="64748B"/>
                 </a:solidFill>
@@ -20276,7 +20235,7 @@
               </a:rPr>
               <a:t>Em 2015 veio a virada: geração compartilhada e créditos por sessenta meses. É daí que nasce o negócio da assinatura.</a:t>
             </a:r>
-            <a:endParaRPr lang="en-US" sz="1300" dirty="0"/>
+            <a:endParaRPr lang="en-US" sz="1400" dirty="0"/>
           </a:p>
         </p:txBody>
       </p:sp>
@@ -20407,7 +20366,7 @@
             <a:r>
               <a:rPr lang="en-US" sz="11000" b="1" dirty="0">
                 <a:solidFill>
-                  <a:srgbClr val="11396F"/>
+                  <a:srgbClr val="F7A23B"/>
                 </a:solidFill>
                 <a:latin typeface="Arial" pitchFamily="34" charset="0"/>
                 <a:ea typeface="Arial" pitchFamily="34" charset="-122"/>
@@ -20595,7 +20554,7 @@
                 <a:ea typeface="Arial" pitchFamily="34" charset="-122"/>
                 <a:cs typeface="Arial" pitchFamily="34" charset="-120"/>
               </a:rPr>
-              <a:t>concessionária, tarifa GD e a calculadora de Fio B</a:t>
+              <a:t>Concessionária, tarifa GD e a calculadora de Fio B</a:t>
             </a:r>
             <a:endParaRPr lang="en-US" sz="3200" dirty="0"/>
           </a:p>
@@ -29085,7 +29044,7 @@
               <a:buNone/>
             </a:pPr>
             <a:r>
-              <a:rPr lang="en-US" sz="1300" i="1" dirty="0">
+              <a:rPr lang="en-US" sz="1400" i="1" dirty="0">
                 <a:solidFill>
                   <a:srgbClr val="64748B"/>
                 </a:solidFill>
@@ -29095,7 +29054,7 @@
               </a:rPr>
               <a:t>Em 2022, a Lei 14.300 trouxe segurança jurídica, a transição do Fio B e o direito adquirido até 2045.</a:t>
             </a:r>
-            <a:endParaRPr lang="en-US" sz="1300" dirty="0"/>
+            <a:endParaRPr lang="en-US" sz="1400" dirty="0"/>
           </a:p>
         </p:txBody>
       </p:sp>
@@ -29305,7 +29264,7 @@
               <a:buNone/>
             </a:pPr>
             <a:r>
-              <a:rPr lang="en-US" sz="1300" i="1" dirty="0">
+              <a:rPr lang="en-US" sz="1400" i="1" dirty="0">
                 <a:solidFill>
                   <a:srgbClr val="64748B"/>
                 </a:solidFill>
@@ -29315,7 +29274,7 @@
               </a:rPr>
               <a:t>Em 2023, a ANEEL regulamentou a lei. Os detalhes operacionais estão na Resolução Normativa mil.</a:t>
             </a:r>
-            <a:endParaRPr lang="en-US" sz="1300" dirty="0"/>
+            <a:endParaRPr lang="en-US" sz="1400" dirty="0"/>
           </a:p>
         </p:txBody>
       </p:sp>
@@ -29546,7 +29505,7 @@
               <a:buNone/>
             </a:pPr>
             <a:r>
-              <a:rPr lang="en-US" sz="1300" i="1" dirty="0">
+              <a:rPr lang="en-US" sz="1400" i="1" dirty="0">
                 <a:solidFill>
                   <a:srgbClr val="64748B"/>
                 </a:solidFill>
@@ -29556,7 +29515,7 @@
               </a:rPr>
               <a:t>O mercado é grande e consolidado, mas a regra muda. Empresa saudável acompanha a regulação e faz contas com cenários.</a:t>
             </a:r>
-            <a:endParaRPr lang="en-US" sz="1300" dirty="0"/>
+            <a:endParaRPr lang="en-US" sz="1400" dirty="0"/>
           </a:p>
         </p:txBody>
       </p:sp>
@@ -29687,7 +29646,7 @@
             <a:r>
               <a:rPr lang="en-US" sz="11000" b="1" dirty="0">
                 <a:solidFill>
-                  <a:srgbClr val="11396F"/>
+                  <a:srgbClr val="F7A23B"/>
                 </a:solidFill>
                 <a:latin typeface="Arial" pitchFamily="34" charset="0"/>
                 <a:ea typeface="Arial" pitchFamily="34" charset="-122"/>
@@ -29810,7 +29769,7 @@
                 <a:ea typeface="Arial" pitchFamily="34" charset="-122"/>
                 <a:cs typeface="Arial" pitchFamily="34" charset="-120"/>
               </a:rPr>
-              <a:t>Aula</a:t>
+              <a:t>Aula teórica</a:t>
             </a:r>
             <a:endParaRPr lang="en-US" sz="1400" dirty="0"/>
           </a:p>
@@ -30430,7 +30389,7 @@
               <a:buNone/>
             </a:pPr>
             <a:r>
-              <a:rPr lang="en-US" sz="1300" i="1" dirty="0">
+              <a:rPr lang="en-US" sz="1500" i="1" dirty="0">
                 <a:solidFill>
                   <a:srgbClr val="64748B"/>
                 </a:solidFill>
@@ -30440,7 +30399,7 @@
               </a:rPr>
               <a:t>A microgeração vai até setenta e cinco quilowatts. Para assinatura, costuma ser pequena demais.</a:t>
             </a:r>
-            <a:endParaRPr lang="en-US" sz="1300" dirty="0"/>
+            <a:endParaRPr lang="en-US" sz="1500" dirty="0"/>
           </a:p>
         </p:txBody>
       </p:sp>
@@ -30691,7 +30650,7 @@
               <a:buNone/>
             </a:pPr>
             <a:r>
-              <a:rPr lang="en-US" sz="1300" i="1" dirty="0">
+              <a:rPr lang="en-US" sz="1400" i="1" dirty="0">
                 <a:solidFill>
                   <a:srgbClr val="64748B"/>
                 </a:solidFill>
@@ -30701,7 +30660,7 @@
               </a:rPr>
               <a:t>A minigeração vai além, com limite de três megawatts para a solar nas regras atuais. É a faixa das usinas de assinatura.</a:t>
             </a:r>
-            <a:endParaRPr lang="en-US" sz="1300" dirty="0"/>
+            <a:endParaRPr lang="en-US" sz="1400" dirty="0"/>
           </a:p>
         </p:txBody>
       </p:sp>
@@ -31394,7 +31353,7 @@
               <a:buNone/>
             </a:pPr>
             <a:r>
-              <a:rPr lang="en-US" sz="1300" i="1" dirty="0">
+              <a:rPr lang="en-US" sz="1500" i="1" dirty="0">
                 <a:solidFill>
                   <a:srgbClr val="64748B"/>
                 </a:solidFill>
@@ -31404,7 +31363,7 @@
               </a:rPr>
               <a:t>É proibido dividir uma usina grande em várias pequenas para caber nas regras. Desconfie desse atalho.</a:t>
             </a:r>
-            <a:endParaRPr lang="en-US" sz="1300" dirty="0"/>
+            <a:endParaRPr lang="en-US" sz="1500" dirty="0"/>
           </a:p>
         </p:txBody>
       </p:sp>
@@ -31655,7 +31614,7 @@
               <a:buNone/>
             </a:pPr>
             <a:r>
-              <a:rPr lang="en-US" sz="1300" i="1" dirty="0">
+              <a:rPr lang="en-US" sz="1400" i="1" dirty="0">
                 <a:solidFill>
                   <a:srgbClr val="64748B"/>
                 </a:solidFill>
@@ -31665,7 +31624,7 @@
               </a:rPr>
               <a:t>Guarde a marca de quinhentos quilowatts: acima dela entra uma regra mais pesada para certos casos, que vamos ver na aula cinco.</a:t>
             </a:r>
-            <a:endParaRPr lang="en-US" sz="1300" dirty="0"/>
+            <a:endParaRPr lang="en-US" sz="1400" dirty="0"/>
           </a:p>
         </p:txBody>
       </p:sp>
@@ -31796,7 +31755,7 @@
             <a:r>
               <a:rPr lang="en-US" sz="11000" b="1" dirty="0">
                 <a:solidFill>
-                  <a:srgbClr val="11396F"/>
+                  <a:srgbClr val="F7A23B"/>
                 </a:solidFill>
                 <a:latin typeface="Arial" pitchFamily="34" charset="0"/>
                 <a:ea typeface="Arial" pitchFamily="34" charset="-122"/>
@@ -31919,7 +31878,7 @@
                 <a:ea typeface="Arial" pitchFamily="34" charset="-122"/>
                 <a:cs typeface="Arial" pitchFamily="34" charset="-120"/>
               </a:rPr>
-              <a:t>Aula</a:t>
+              <a:t>Aula teórica</a:t>
             </a:r>
             <a:endParaRPr lang="en-US" sz="1400" dirty="0"/>
           </a:p>
@@ -32539,7 +32498,7 @@
               <a:buNone/>
             </a:pPr>
             <a:r>
-              <a:rPr lang="en-US" sz="1300" i="1" dirty="0">
+              <a:rPr lang="en-US" sz="1500" i="1" dirty="0">
                 <a:solidFill>
                   <a:srgbClr val="64748B"/>
                 </a:solidFill>
@@ -32549,7 +32508,7 @@
               </a:rPr>
               <a:t>No autoconsumo local, gera-se e consome-se no mesmo lugar. É o que as integradoras vendem.</a:t>
             </a:r>
-            <a:endParaRPr lang="en-US" sz="1300" dirty="0"/>
+            <a:endParaRPr lang="en-US" sz="1500" dirty="0"/>
           </a:p>
         </p:txBody>
       </p:sp>
@@ -32714,7 +32673,7 @@
               <a:buNone/>
             </a:pPr>
             <a:r>
-              <a:rPr lang="en-US" sz="1300" i="1" dirty="0">
+              <a:rPr lang="en-US" sz="1500" i="1" dirty="0">
                 <a:solidFill>
                   <a:srgbClr val="64748B"/>
                 </a:solidFill>
@@ -32724,7 +32683,7 @@
               </a:rPr>
               <a:t>No autoconsumo remoto, a usina fica em outro lugar, mas os créditos vão só para unidades do mesmo titular.</a:t>
             </a:r>
-            <a:endParaRPr lang="en-US" sz="1300" dirty="0"/>
+            <a:endParaRPr lang="en-US" sz="1500" dirty="0"/>
           </a:p>
         </p:txBody>
       </p:sp>
@@ -32889,7 +32848,7 @@
               <a:buNone/>
             </a:pPr>
             <a:r>
-              <a:rPr lang="en-US" sz="1300" i="1" dirty="0">
+              <a:rPr lang="en-US" sz="1500" i="1" dirty="0">
                 <a:solidFill>
                   <a:srgbClr val="64748B"/>
                 </a:solidFill>
@@ -32899,7 +32858,7 @@
               </a:rPr>
               <a:t>Na geração compartilhada, consumidores diferentes se reúnem numa entidade, como consórcio ou cooperativa, e dividem os créditos. É esse o mecanismo da assinatura.</a:t>
             </a:r>
-            <a:endParaRPr lang="en-US" sz="1300" dirty="0"/>
+            <a:endParaRPr lang="en-US" sz="1500" dirty="0"/>
           </a:p>
         </p:txBody>
       </p:sp>

</xml_diff>